<commit_message>
fix: pigeon DDG screenshots use Firefox; refresh report artifacts
Co-authored-by: boster00 <boster00@users.noreply.github.com>
</commit_message>
<xml_diff>
--- a/docs/results/test-result.pptx
+++ b/docs/results/test-result.pptx
@@ -1173,7 +1173,7 @@
                   <a:srgbClr val="000000"/>
                 </a:solidFill>
               </a:rPr>
-              <a:t>Search: cute hamster pictures</a:t>
+              <a:t>DuckDuckGo: cute hamster pictures</a:t>
             </a:r>
             <a:endParaRPr lang="en-US" sz="2000" dirty="0"/>
           </a:p>
@@ -1258,7 +1258,7 @@
                   <a:srgbClr val="000000"/>
                 </a:solidFill>
               </a:rPr>
-              <a:t>Search: antibody 3D structures</a:t>
+              <a:t>DuckDuckGo: antibody 3D structures</a:t>
             </a:r>
             <a:endParaRPr lang="en-US" sz="2000" dirty="0"/>
           </a:p>

</xml_diff>